<commit_message>
Précise le binôme Brad et Robin sur les tests du moteur
</commit_message>
<xml_diff>
--- a/SOUTENANCE.pptx
+++ b/SOUTENANCE.pptx
@@ -859,7 +859,7 @@
           <a:p>
             <a:r>
               <a:rPr lang="en-US" dirty="0"/>
-              <a:t>Repartition lisible directement dans l'historique Git. Le point a retenir : c'est l'architecture en couches qui a permis de travailler en parallele. La couche calcul ne dependant que du modele, elle a pu etre ecrite des que le modele etait fige ; l'affichage et le moteur ont ete faits en meme temps par deux personnes.</a:t>
+              <a:t>Repartition lisible directement dans l'historique Git. Deux points a retenir. D'abord, c'est l'architecture en couches qui a permis de travailler en parallele : la couche calcul ne dependant que du modele, elle a pu etre ecrite des que le modele etait fige, et l'affichage et le moteur ont ete faits en meme temps par deux personnes. Ensuite, les tests du moteur ont ete ecrits en binome par Brad et Robin : c'etait la partie la plus delicate a verifier, et confronter deux lectures de l'algorithme a fait emerger le cas de contraste sur le cold start.</a:t>
             </a:r>
             <a:endParaRPr lang="en-US" dirty="0"/>
           </a:p>
@@ -2501,7 +2501,7 @@
                 <a:ea typeface="Calibri" pitchFamily="34" charset="-122"/>
                 <a:cs typeface="Calibri" pitchFamily="34" charset="-120"/>
               </a:rPr>
-              <a:t>Séance 1 — structure sbt, jeu de données, modèle du domaine, README de cadrage. Puis les tests du moteur.</a:t>
+              <a:t>Séance 1 — structure sbt, jeu de données, modèle du domaine, README de cadrage.</a:t>
             </a:r>
             <a:endParaRPr lang="en-US" sz="1200" dirty="0"/>
           </a:p>
@@ -3033,13 +3033,13 @@
             <a:r>
               <a:rPr lang="en-US" sz="1500" b="1" dirty="0">
                 <a:solidFill>
-                  <a:srgbClr val="FFFFFF"/>
+                  <a:srgbClr val="F96167"/>
                 </a:solidFill>
                 <a:latin typeface="Calibri" pitchFamily="34" charset="0"/>
                 <a:ea typeface="Calibri" pitchFamily="34" charset="-122"/>
                 <a:cs typeface="Calibri" pitchFamily="34" charset="-120"/>
               </a:rPr>
-              <a:t>Le découpage en couches a rendu le travail en parallèle possible.
+              <a:t>Les tests du moteur : écrits à deux, par Brad et Robin.
 </a:t>
             </a:r>
             <a:endParaRPr lang="en-US" sz="1500" dirty="0"/>
@@ -3057,7 +3057,7 @@
                 <a:ea typeface="Calibri" pitchFamily="34" charset="-122"/>
                 <a:cs typeface="Calibri" pitchFamily="34" charset="-120"/>
               </a:rPr>
-              <a:t>La couche calcul ne dépend que du modèle : elle a pu être écrite une fois le modèle figé. L'affichage et le moteur ont été développés en même temps, par deux personnes différentes.</a:t>
+              <a:t>C'était le morceau le plus délicat à vérifier. Travailler en binôme a permis de confronter deux lectures de l'algorithme — c'est de là qu'est venu le cas de contraste sur le cold start.</a:t>
             </a:r>
             <a:endParaRPr lang="en-US" sz="1500" dirty="0"/>
           </a:p>

</xml_diff>

<commit_message>
Retire les formules mathématiques du support de soutenance
</commit_message>
<xml_diff>
--- a/SOUTENANCE.pptx
+++ b/SOUTENANCE.pptx
@@ -771,7 +771,7 @@
           <a:p>
             <a:r>
               <a:rPr lang="en-US" dirty="0"/>
-              <a:t>0:00-0:40. Bonjour. Je presente un prototype de moteur de recommandation pour TechMarket, un site e-commerce high-tech, developpe en Scala 3 en programmation fonctionnelle pure. En 10 minutes : le probleme metier, l'architecture, la formule de scoring, les resultats sur le jeu de donnees fourni, et la demarche qualite.</a:t>
+              <a:t>0:00-0:40. Bonjour. Nous presentons un prototype de moteur de recommandation pour TechMarket, un site e-commerce high-tech, developpe en Scala 3 en programmation fonctionnelle. En 10 minutes : le probleme metier, l architecture, la facon dont le moteur choisit les produits, les resultats sur le jeu de donnees fourni, et notre demarche qualite.</a:t>
             </a:r>
             <a:endParaRPr lang="en-US" dirty="0"/>
           </a:p>
@@ -1396,7 +1396,7 @@
           <a:p>
             <a:r>
               <a:rPr lang="en-US" dirty="0"/>
-              <a:t>3:40-4:50. La similarite entre deux utilisateurs est le cosinus de l'angle entre leurs profils. Un profil : une coordonnee par produit, valant le signal le plus fort emis — pas la somme, pour qu'un curieux compulsif ne pese pas plus qu'un acheteur. Le cosinus ignore le volume d'activite et ne compare que la direction du gout : c'est exactement ce qu'il faut pour le taux de clic. Jaccard aurait perdu l'intensite, l'euclidienne aurait separe des gouts identiques d'activite differente.</a:t>
+              <a:t>3:40-4:50. Le principe du filtrage collaboratif : on recommande a un client ce qu'ont aime les gens qui lui ressemblent. Trois etapes. D'abord chaque action recoit un poids : vue 1, note sa valeur, achat 5 ; si quelqu'un voit puis achete le meme produit on garde le maximum, sinon un curieux qui consulte dix fois une fiche peserait plus lourd qu'un acheteur. Ensuite on compare les gouts, sans tenir compte du volume d'activite : un client tres actif et un client discret qui aiment les memes choses sont consideres comme proches. Enfin on propose ce que ces voisins ont apprecie, en excluant ce que le client connait deja. SI ON DEMANDE LA FORMULE : c'est la similarite cosinus, detaillee dans le rapport section 4.</a:t>
             </a:r>
             <a:endParaRPr lang="en-US" dirty="0"/>
           </a:p>
@@ -2660,7 +2660,7 @@
                 <a:ea typeface="Calibri" pitchFamily="34" charset="-122"/>
                 <a:cs typeface="Calibri" pitchFamily="34" charset="-120"/>
               </a:rPr>
-              <a:t>Séance 2 — le cœur fonctionnel : similarité cosinus, poids et profils, chargement des CSV, et leurs tests.</a:t>
+              <a:t>Séance 2 — le cœur fonctionnel : comparaison des goûts, poids et profils, chargement des CSV, et leurs tests.</a:t>
             </a:r>
             <a:endParaRPr lang="en-US" sz="1200" dirty="0"/>
           </a:p>
@@ -3776,7 +3776,7 @@
                 <a:ea typeface="Calibri" pitchFamily="34" charset="-122"/>
                 <a:cs typeface="Calibri" pitchFamily="34" charset="-120"/>
               </a:rPr>
-              <a:t>voisins de goût par cosinus, top-N trié</a:t>
+              <a:t>on propose ce qu'ont aimé les clients qui vous ressemblent</a:t>
             </a:r>
             <a:endParaRPr lang="en-US" sz="1450" dirty="0"/>
           </a:p>
@@ -5787,7 +5787,7 @@
                 <a:ea typeface="Calibri" pitchFamily="34" charset="-122"/>
                 <a:cs typeface="Calibri" pitchFamily="34" charset="-120"/>
               </a:rPr>
-              <a:t>fonctions pures — cosinus, poids, profils, popularité</a:t>
+              <a:t>fonctions pures — poids des actions, profils, popularité</a:t>
             </a:r>
             <a:endParaRPr lang="en-US" sz="1250" dirty="0"/>
           </a:p>
@@ -6334,7 +6334,7 @@
                 <a:ea typeface="Cambria" pitchFamily="34" charset="-122"/>
                 <a:cs typeface="Cambria" pitchFamily="34" charset="-120"/>
               </a:rPr>
-              <a:t>La mesure : similarité cosinus</a:t>
+              <a:t>Comment on trouve les bons produits</a:t>
             </a:r>
             <a:endParaRPr lang="en-US" sz="3200" dirty="0"/>
           </a:p>
@@ -6370,8 +6370,8 @@
         </p:nvSpPr>
         <p:spPr>
           <a:xfrm>
-            <a:off x="914400" y="1463040"/>
-            <a:ext cx="10360152" cy="1371600"/>
+            <a:off x="914400" y="1691640"/>
+            <a:ext cx="10360152" cy="1005840"/>
           </a:xfrm>
           <a:prstGeom prst="rect">
             <a:avLst/>
@@ -6391,11 +6391,29 @@
                 <a:solidFill>
                   <a:srgbClr val="FFFFFF"/>
                 </a:solidFill>
-                <a:latin typeface="Courier New" pitchFamily="34" charset="0"/>
-                <a:ea typeface="Courier New" pitchFamily="34" charset="-122"/>
-                <a:cs typeface="Courier New" pitchFamily="34" charset="-120"/>
-              </a:rPr>
-              <a:t>cos(u, v)  =  u · v  /  ( ‖u‖ × ‖v‖ )          (Vector[Double], Vector[Double]) =&gt; Double</a:t>
+                <a:latin typeface="Calibri" pitchFamily="34" charset="0"/>
+                <a:ea typeface="Calibri" pitchFamily="34" charset="-122"/>
+                <a:cs typeface="Calibri" pitchFamily="34" charset="-120"/>
+              </a:rPr>
+              <a:t>L'idée : on recommande à un client ce qu'ont aimé les gens qui lui ressemblent.
+</a:t>
+            </a:r>
+            <a:endParaRPr lang="en-US" sz="1700" dirty="0"/>
+          </a:p>
+          <a:p>
+            <a:pPr indent="0" marL="0">
+              <a:buNone/>
+            </a:pPr>
+            <a:r>
+              <a:rPr lang="en-US" sz="1450" dirty="0">
+                <a:solidFill>
+                  <a:srgbClr val="CADCFC"/>
+                </a:solidFill>
+                <a:latin typeface="Calibri" pitchFamily="34" charset="0"/>
+                <a:ea typeface="Calibri" pitchFamily="34" charset="-122"/>
+                <a:cs typeface="Calibri" pitchFamily="34" charset="-120"/>
+              </a:rPr>
+              <a:t>Encore faut-il savoir qui « lui ressemble ».</a:t>
             </a:r>
             <a:endParaRPr lang="en-US" sz="1700" dirty="0"/>
           </a:p>
@@ -6456,7 +6474,7 @@
                 <a:ea typeface="Calibri" pitchFamily="34" charset="-122"/>
                 <a:cs typeface="Calibri" pitchFamily="34" charset="-120"/>
               </a:rPr>
-              <a:t>Le profil d'un utilisateur</a:t>
+              <a:t>1. Chaque action a un poids</a:t>
             </a:r>
             <a:endParaRPr lang="en-US" sz="1550" dirty="0"/>
           </a:p>
@@ -6495,7 +6513,7 @@
                 <a:ea typeface="Calibri" pitchFamily="34" charset="-122"/>
                 <a:cs typeface="Calibri" pitchFamily="34" charset="-120"/>
               </a:rPr>
-              <a:t>une coordonnée par item : le signal le plus fort émis — vue 1, note 1 à 5, achat 5. Vu PUIS acheté = max, pas la somme.</a:t>
+              <a:t>une vue compte pour 1, une note pour sa valeur, un achat pour 5. Si quelqu'un voit puis achète, on garde le signal le plus fort — pas les deux.</a:t>
             </a:r>
             <a:endParaRPr lang="en-US" sz="1300" dirty="0"/>
           </a:p>
@@ -6556,7 +6574,7 @@
                 <a:ea typeface="Calibri" pitchFamily="34" charset="-122"/>
                 <a:cs typeface="Calibri" pitchFamily="34" charset="-120"/>
               </a:rPr>
-              <a:t>Pourquoi le cosinus</a:t>
+              <a:t>2. On compare les goûts</a:t>
             </a:r>
             <a:endParaRPr lang="en-US" sz="1550" dirty="0"/>
           </a:p>
@@ -6595,7 +6613,7 @@
                 <a:ea typeface="Calibri" pitchFamily="34" charset="-122"/>
                 <a:cs typeface="Calibri" pitchFamily="34" charset="-120"/>
               </a:rPr>
-              <a:t>insensible à l'intensité d'activité : il compare des directions de goût. Un fidèle très actif et un occasionnel discret peuvent être très proches.</a:t>
+              <a:t>deux clients sont proches s'ils s'intéressent aux mêmes produits, même si l'un est bien plus actif que l'autre.</a:t>
             </a:r>
             <a:endParaRPr lang="en-US" sz="1300" dirty="0"/>
           </a:p>
@@ -6656,7 +6674,7 @@
                 <a:ea typeface="Calibri" pitchFamily="34" charset="-122"/>
                 <a:cs typeface="Calibri" pitchFamily="34" charset="-120"/>
               </a:rPr>
-              <a:t>Le lien métier</a:t>
+              <a:t>3. On propose leurs coups de cœur</a:t>
             </a:r>
             <a:endParaRPr lang="en-US" sz="1550" dirty="0"/>
           </a:p>
@@ -6695,7 +6713,7 @@
                 <a:ea typeface="Calibri" pitchFamily="34" charset="-122"/>
                 <a:cs typeface="Calibri" pitchFamily="34" charset="-120"/>
               </a:rPr>
-              <a:t>des voisins de goût, pas de gros acheteurs : la suggestion a une vraie chance de plaire — c'est l'objectif « taux de clic ».</a:t>
+              <a:t>les produits appréciés par ces voisins, jamais ceux que le client connaît déjà. C'est l'objectif « taux de clic ».</a:t>
             </a:r>
             <a:endParaRPr lang="en-US" sz="1300" dirty="0"/>
           </a:p>
@@ -8952,7 +8970,7 @@
                 <a:ea typeface="Cambria" pitchFamily="34" charset="-122"/>
                 <a:cs typeface="Cambria" pitchFamily="34" charset="-120"/>
               </a:rPr>
-              <a:t>Un test vert ne prouve rien : la revue par mutation</a:t>
+              <a:t>Un test qui passe ne prouve pas que le code est bon</a:t>
             </a:r>
             <a:endParaRPr lang="en-US" sz="3200" dirty="0"/>
           </a:p>
@@ -9013,7 +9031,7 @@
                 <a:ea typeface="Calibri" pitchFamily="34" charset="-122"/>
                 <a:cs typeface="Calibri" pitchFamily="34" charset="-120"/>
               </a:rPr>
-              <a:t>Méthode : </a:t>
+              <a:t>Notre méthode : </a:t>
             </a:r>
             <a:pPr indent="0" marL="0">
               <a:buNone/>
@@ -9027,7 +9045,7 @@
                 <a:ea typeface="Calibri" pitchFamily="34" charset="-122"/>
                 <a:cs typeface="Calibri" pitchFamily="34" charset="-120"/>
               </a:rPr>
-              <a:t>casser volontairement le code et vérifier que la suite rougit. Trois mutations majeures survivaient à la première suite : supprimer la gestion du segment, supprimer la pondération par similarité, dupliquer les contributions.</a:t>
+              <a:t>casser le code exprès, et vérifier que les tests s'en aperçoivent. Résultat : on pouvait supprimer des morceaux entiers du moteur sans qu'un seul test échoue. Nos premiers tests ne vérifiaient donc pas grand-chose.</a:t>
             </a:r>
             <a:endParaRPr lang="en-US" sz="1450" dirty="0"/>
           </a:p>
@@ -9127,7 +9145,7 @@
                 <a:ea typeface="Calibri" pitchFamily="34" charset="-122"/>
                 <a:cs typeface="Calibri" pitchFamily="34" charset="-120"/>
               </a:rPr>
-              <a:t>un voisin qui a acheté PUIS noté le même produit comptait deux fois : sim × (5 + note) au lieu de sim × max</a:t>
+              <a:t>un client qui avait acheté PUIS noté le même produit était compté deux fois dans le calcul</a:t>
             </a:r>
             <a:endParaRPr lang="en-US" sz="1250" dirty="0"/>
           </a:p>
@@ -9227,7 +9245,7 @@
                 <a:ea typeface="Calibri" pitchFamily="34" charset="-122"/>
                 <a:cs typeface="Calibri" pitchFamily="34" charset="-120"/>
               </a:rPr>
-              <a:t>l'ordre du top-3 changeait pour 6 des 13 utilisateurs personnalisables du jeu de données</a:t>
+              <a:t>l'ordre des 3 produits proposés changeait pour 6 clients sur 13</a:t>
             </a:r>
             <a:endParaRPr lang="en-US" sz="1250" dirty="0"/>
           </a:p>
@@ -9288,7 +9306,7 @@
                 <a:ea typeface="Calibri" pitchFamily="34" charset="-122"/>
                 <a:cs typeface="Calibri" pitchFamily="34" charset="-120"/>
               </a:rPr>
-              <a:t>Le verrou posé</a:t>
+              <a:t>Ce qu'on a fait</a:t>
             </a:r>
             <a:endParaRPr lang="en-US" sz="1550" dirty="0"/>
           </a:p>
@@ -9327,7 +9345,7 @@
                 <a:ea typeface="Calibri" pitchFamily="34" charset="-122"/>
                 <a:cs typeface="Calibri" pitchFamily="34" charset="-120"/>
               </a:rPr>
-              <a:t>règle « signal le plus fort » factorisée (poidsParItem), score exact 5/racine(2) asserté à 1e-9 près, fixture de contraste David</a:t>
+              <a:t>corrigé le calcul, puis ajouté des tests qui échouent vraiment si on casse le moteur</a:t>
             </a:r>
             <a:endParaRPr lang="en-US" sz="1250" dirty="0"/>
           </a:p>

</xml_diff>